<commit_message>
Rework the four e-aircraft example decks image-led (0.10-draft)
Feedback: left-heavy, no images. Added vector illustrations (art.js, SVG and
PNG), rebuilt read, talk, pitch and update with balanced layouts, full-bleed
picture grounds with text plates, larger exhibits, status as colour fields.
Script: table cell fills are read for contrast and colour use; plan contrast
uses the best declared background. Findings on composition rules, fill limits
and pptxgenjs margin order recorded, rule values unchanged.

Co-Authored-By: Claude Sonnet 5 <noreply@anthropic.com>
</commit_message>
<xml_diff>
--- a/examples/e-flugzeuge/pitch/deck.pptx
+++ b/examples/e-flugzeuge/pitch/deck.pptx
@@ -2132,7 +2132,7 @@
         <p:spPr>
           <a:xfrm>
             <a:off x="609600" y="2032000"/>
-            <a:ext cx="9753600" cy="1422400"/>
+            <a:ext cx="6096000" cy="2032000"/>
           </a:xfrm>
           <a:prstGeom prst="rect">
             <a:avLst/>
@@ -2160,54 +2160,6 @@
               <a:buNone/>
             </a:pPr>
             <a:endParaRPr lang="en-US" sz="4400" dirty="0"/>
-          </a:p>
-        </p:txBody>
-      </p:sp>
-      <p:sp>
-        <p:nvSpPr>
-          <p:cNvPr id="25" name="Slide Number Placeholder 0"/>
-          <p:cNvSpPr>
-            <a:spLocks noGrp="1"/>
-          </p:cNvSpPr>
-          <p:nvPr>
-            <p:ph type="sldNum" sz="quarter" idx="4294967295"/>
-          </p:nvPr>
-        </p:nvSpPr>
-        <p:spPr>
-          <a:xfrm>
-            <a:off x="10972800" y="5791200"/>
-            <a:ext cx="609600" cy="304800"/>
-          </a:xfrm>
-          <a:prstGeom prst="rect">
-            <a:avLst/>
-          </a:prstGeom>
-          <a:extLst>
-            <a:ext uri="{C572A759-6A51-4108-AA02-DFA0A04FC94B}">
-              <ma14:wrappingTextBoxFlag xmlns:ma14="http://schemas.microsoft.com/office/mac/drawingml/2011/main" val="0"/>
-            </a:ext>
-          </a:extLst>
-        </p:spPr>
-        <p:txBody>
-          <a:bodyPr/>
-          <a:lstStyle>
-            <a:lvl1pPr>
-              <a:defRPr sz="1000">
-                <a:solidFill>
-                  <a:srgbClr val="5B6470"/>
-                </a:solidFill>
-                <a:latin typeface="Calibri"/>
-                <a:ea typeface="Calibri"/>
-                <a:cs typeface="Calibri"/>
-              </a:defRPr>
-            </a:lvl1pPr>
-          </a:lstStyle>
-          <a:p>
-            <a:pPr algn="r"/>
-            <a:fld id="{F7021451-1387-4CA6-816F-3879F97B5CBC}" type="slidenum">
-              <a:rPr b="0" lang="en-US"/>
-              <a:t>1002</a:t>
-            </a:fld>
-            <a:endParaRPr lang="en-US"/>
           </a:p>
         </p:txBody>
       </p:sp>
@@ -2282,54 +2234,6 @@
               <a:buNone/>
             </a:pPr>
             <a:endParaRPr lang="en-US" sz="3200" dirty="0"/>
-          </a:p>
-        </p:txBody>
-      </p:sp>
-      <p:sp>
-        <p:nvSpPr>
-          <p:cNvPr id="25" name="Slide Number Placeholder 0"/>
-          <p:cNvSpPr>
-            <a:spLocks noGrp="1"/>
-          </p:cNvSpPr>
-          <p:nvPr>
-            <p:ph type="sldNum" sz="quarter" idx="4294967295"/>
-          </p:nvPr>
-        </p:nvSpPr>
-        <p:spPr>
-          <a:xfrm>
-            <a:off x="10972800" y="5791200"/>
-            <a:ext cx="609600" cy="304800"/>
-          </a:xfrm>
-          <a:prstGeom prst="rect">
-            <a:avLst/>
-          </a:prstGeom>
-          <a:extLst>
-            <a:ext uri="{C572A759-6A51-4108-AA02-DFA0A04FC94B}">
-              <ma14:wrappingTextBoxFlag xmlns:ma14="http://schemas.microsoft.com/office/mac/drawingml/2011/main" val="0"/>
-            </a:ext>
-          </a:extLst>
-        </p:spPr>
-        <p:txBody>
-          <a:bodyPr/>
-          <a:lstStyle>
-            <a:lvl1pPr>
-              <a:defRPr sz="1000">
-                <a:solidFill>
-                  <a:srgbClr val="5B6470"/>
-                </a:solidFill>
-                <a:latin typeface="Calibri"/>
-                <a:ea typeface="Calibri"/>
-                <a:cs typeface="Calibri"/>
-              </a:defRPr>
-            </a:lvl1pPr>
-          </a:lstStyle>
-          <a:p>
-            <a:pPr algn="r"/>
-            <a:fld id="{F7021451-1387-4CA6-816F-3879F97B5CBC}" type="slidenum">
-              <a:rPr b="0" lang="en-US"/>
-              <a:t>1003</a:t>
-            </a:fld>
-            <a:endParaRPr lang="en-US"/>
           </a:p>
         </p:txBody>
       </p:sp>
@@ -2931,9 +2835,53 @@
           <a:chExt cx="0" cy="0"/>
         </a:xfrm>
       </p:grpSpPr>
-      <p:sp>
-        <p:nvSpPr>
-          <p:cNvPr id="2" name="Text 0"/>
+      <p:pic>
+        <p:nvPicPr>
+          <p:cNvPr id="2" name="Image 0" descr="Illustration: Elektroflugzeug in Magenta in der Draufsicht über hellgrauen Ringen">    </p:cNvPr>
+          <p:cNvPicPr>
+            <a:picLocks noChangeAspect="1"/>
+          </p:cNvPicPr>
+          <p:nvPr/>
+        </p:nvPicPr>
+        <p:blipFill>
+          <a:blip r:embed="rId1"/>
+          <a:stretch>
+            <a:fillRect/>
+          </a:stretch>
+        </p:blipFill>
+        <p:spPr>
+          <a:xfrm>
+            <a:off x="0" y="0"/>
+            <a:ext cx="12192000" cy="6858000"/>
+          </a:xfrm>
+          <a:prstGeom prst="rect">
+            <a:avLst/>
+          </a:prstGeom>
+        </p:spPr>
+      </p:pic>
+      <p:sp>
+        <p:nvSpPr>
+          <p:cNvPr id="3" name="Shape 0"/>
+          <p:cNvSpPr/>
+          <p:nvPr/>
+        </p:nvSpPr>
+        <p:spPr>
+          <a:xfrm>
+            <a:off x="609600" y="2032000"/>
+            <a:ext cx="6096000" cy="2032000"/>
+          </a:xfrm>
+          <a:prstGeom prst="rect">
+            <a:avLst/>
+          </a:prstGeom>
+          <a:solidFill>
+            <a:srgbClr val="FFFFFF"/>
+          </a:solidFill>
+          <a:ln/>
+        </p:spPr>
+      </p:sp>
+      <p:sp>
+        <p:nvSpPr>
+          <p:cNvPr id="4" name="Text 0"/>
           <p:cNvSpPr/>
           <p:nvPr>
             <p:ph idx="100" type="title" hasCustomPrompt="1"/>
@@ -2942,7 +2890,7 @@
         <p:spPr>
           <a:xfrm>
             <a:off x="609600" y="2032000"/>
-            <a:ext cx="9753600" cy="1422400"/>
+            <a:ext cx="6096000" cy="2032000"/>
           </a:xfrm>
           <a:prstGeom prst="rect">
             <a:avLst/>
@@ -2974,19 +2922,21 @@
       </p:sp>
       <p:sp>
         <p:nvSpPr>
-          <p:cNvPr id="3" name="Text 1"/>
+          <p:cNvPr id="5" name="Text 2"/>
           <p:cNvSpPr txBox="1"/>
           <p:nvPr/>
         </p:nvSpPr>
         <p:spPr>
           <a:xfrm>
-            <a:off x="609600" y="3657600"/>
-            <a:ext cx="9753600" cy="406400"/>
+            <a:off x="609600" y="4267200"/>
+            <a:ext cx="6096000" cy="406400"/>
           </a:xfrm>
           <a:prstGeom prst="rect">
             <a:avLst/>
           </a:prstGeom>
-          <a:noFill/>
+          <a:solidFill>
+            <a:srgbClr val="FFFFFF"/>
+          </a:solidFill>
           <a:ln/>
         </p:spPr>
         <p:txBody>
@@ -3008,54 +2958,6 @@
               <a:t>Seed-Runde, Beispieldaten</a:t>
             </a:r>
             <a:endParaRPr lang="en-US" sz="2000" dirty="0"/>
-          </a:p>
-        </p:txBody>
-      </p:sp>
-      <p:sp>
-        <p:nvSpPr>
-          <p:cNvPr id="25" name="Slide Number Placeholder 0"/>
-          <p:cNvSpPr>
-            <a:spLocks noGrp="1"/>
-          </p:cNvSpPr>
-          <p:nvPr>
-            <p:ph type="sldNum" sz="quarter" idx="4294967295"/>
-          </p:nvPr>
-        </p:nvSpPr>
-        <p:spPr>
-          <a:xfrm>
-            <a:off x="10972800" y="5791200"/>
-            <a:ext cx="609600" cy="304800"/>
-          </a:xfrm>
-          <a:prstGeom prst="rect">
-            <a:avLst/>
-          </a:prstGeom>
-          <a:extLst>
-            <a:ext uri="{C572A759-6A51-4108-AA02-DFA0A04FC94B}">
-              <ma14:wrappingTextBoxFlag xmlns:ma14="http://schemas.microsoft.com/office/mac/drawingml/2011/main" val="0"/>
-            </a:ext>
-          </a:extLst>
-        </p:spPr>
-        <p:txBody>
-          <a:bodyPr/>
-          <a:lstStyle>
-            <a:lvl1pPr>
-              <a:defRPr sz="1000">
-                <a:solidFill>
-                  <a:srgbClr val="5B6470"/>
-                </a:solidFill>
-                <a:latin typeface="Calibri"/>
-                <a:ea typeface="Calibri"/>
-                <a:cs typeface="Calibri"/>
-              </a:defRPr>
-            </a:lvl1pPr>
-          </a:lstStyle>
-          <a:p>
-            <a:pPr algn="r"/>
-            <a:fld id="{F7021451-1387-4CA6-816F-3879F97B5CBC}" type="slidenum">
-              <a:rPr b="0" lang="en-US"/>
-              <a:t>1</a:t>
-            </a:fld>
-            <a:endParaRPr lang="en-US"/>
           </a:p>
         </p:txBody>
       </p:sp>
@@ -3084,9 +2986,53 @@
           <a:chExt cx="0" cy="0"/>
         </a:xfrm>
       </p:grpSpPr>
-      <p:sp>
-        <p:nvSpPr>
-          <p:cNvPr id="2" name="Text 0"/>
+      <p:pic>
+        <p:nvPicPr>
+          <p:cNvPr id="2" name="Image 0" descr="Illustration: Turboprop-Flugzeug in Grau mit Schallwellen und einer Abgasfahne nach rechts">    </p:cNvPr>
+          <p:cNvPicPr>
+            <a:picLocks noChangeAspect="1"/>
+          </p:cNvPicPr>
+          <p:nvPr/>
+        </p:nvPicPr>
+        <p:blipFill>
+          <a:blip r:embed="rId1"/>
+          <a:stretch>
+            <a:fillRect/>
+          </a:stretch>
+        </p:blipFill>
+        <p:spPr>
+          <a:xfrm>
+            <a:off x="0" y="0"/>
+            <a:ext cx="12192000" cy="6858000"/>
+          </a:xfrm>
+          <a:prstGeom prst="rect">
+            <a:avLst/>
+          </a:prstGeom>
+        </p:spPr>
+      </p:pic>
+      <p:sp>
+        <p:nvSpPr>
+          <p:cNvPr id="3" name="Shape 0"/>
+          <p:cNvSpPr/>
+          <p:nvPr/>
+        </p:nvSpPr>
+        <p:spPr>
+          <a:xfrm>
+            <a:off x="609600" y="609600"/>
+            <a:ext cx="10972800" cy="508000"/>
+          </a:xfrm>
+          <a:prstGeom prst="rect">
+            <a:avLst/>
+          </a:prstGeom>
+          <a:solidFill>
+            <a:srgbClr val="FFFFFF"/>
+          </a:solidFill>
+          <a:ln/>
+        </p:spPr>
+      </p:sp>
+      <p:sp>
+        <p:nvSpPr>
+          <p:cNvPr id="4" name="Text 0"/>
           <p:cNvSpPr/>
           <p:nvPr>
             <p:ph idx="100" type="title" hasCustomPrompt="1"/>
@@ -3127,19 +3073,21 @@
       </p:sp>
       <p:sp>
         <p:nvSpPr>
-          <p:cNvPr id="3" name="Text 1"/>
+          <p:cNvPr id="5" name="Text 2"/>
           <p:cNvSpPr txBox="1"/>
           <p:nvPr/>
         </p:nvSpPr>
         <p:spPr>
           <a:xfrm>
-            <a:off x="609600" y="1625600"/>
-            <a:ext cx="7315200" cy="2032000"/>
+            <a:off x="609600" y="1828800"/>
+            <a:ext cx="5791200" cy="2032000"/>
           </a:xfrm>
           <a:prstGeom prst="rect">
             <a:avLst/>
           </a:prstGeom>
-          <a:noFill/>
+          <a:solidFill>
+            <a:srgbClr val="FFFFFF"/>
+          </a:solidFill>
           <a:ln/>
         </p:spPr>
         <p:txBody>
@@ -3204,54 +3152,6 @@
               <a:t>Jeder Passagier verursacht 112 g CO₂ je Kilometer.</a:t>
             </a:r>
             <a:endParaRPr lang="en-US" sz="2000" dirty="0"/>
-          </a:p>
-        </p:txBody>
-      </p:sp>
-      <p:sp>
-        <p:nvSpPr>
-          <p:cNvPr id="25" name="Slide Number Placeholder 0"/>
-          <p:cNvSpPr>
-            <a:spLocks noGrp="1"/>
-          </p:cNvSpPr>
-          <p:nvPr>
-            <p:ph type="sldNum" sz="quarter" idx="4294967295"/>
-          </p:nvPr>
-        </p:nvSpPr>
-        <p:spPr>
-          <a:xfrm>
-            <a:off x="10972800" y="5791200"/>
-            <a:ext cx="609600" cy="304800"/>
-          </a:xfrm>
-          <a:prstGeom prst="rect">
-            <a:avLst/>
-          </a:prstGeom>
-          <a:extLst>
-            <a:ext uri="{C572A759-6A51-4108-AA02-DFA0A04FC94B}">
-              <ma14:wrappingTextBoxFlag xmlns:ma14="http://schemas.microsoft.com/office/mac/drawingml/2011/main" val="0"/>
-            </a:ext>
-          </a:extLst>
-        </p:spPr>
-        <p:txBody>
-          <a:bodyPr/>
-          <a:lstStyle>
-            <a:lvl1pPr>
-              <a:defRPr sz="1000">
-                <a:solidFill>
-                  <a:srgbClr val="5B6470"/>
-                </a:solidFill>
-                <a:latin typeface="Calibri"/>
-                <a:ea typeface="Calibri"/>
-                <a:cs typeface="Calibri"/>
-              </a:defRPr>
-            </a:lvl1pPr>
-          </a:lstStyle>
-          <a:p>
-            <a:pPr algn="r"/>
-            <a:fld id="{F7021451-1387-4CA6-816F-3879F97B5CBC}" type="slidenum">
-              <a:rPr b="0" lang="en-US"/>
-              <a:t>2</a:t>
-            </a:fld>
-            <a:endParaRPr lang="en-US"/>
           </a:p>
         </p:txBody>
       </p:sp>
@@ -3321,6 +3221,68 @@
           </a:p>
         </p:txBody>
       </p:sp>
+      <p:sp>
+        <p:nvSpPr>
+          <p:cNvPr id="3" name="Text 1"/>
+          <p:cNvSpPr txBox="1"/>
+          <p:nvPr/>
+        </p:nvSpPr>
+        <p:spPr>
+          <a:xfrm>
+            <a:off x="609600" y="1625600"/>
+            <a:ext cx="3759200" cy="1524000"/>
+          </a:xfrm>
+          <a:prstGeom prst="rect">
+            <a:avLst/>
+          </a:prstGeom>
+          <a:noFill/>
+          <a:ln/>
+        </p:spPr>
+        <p:txBody>
+          <a:bodyPr wrap="square" lIns="0" tIns="0" rIns="0" bIns="0" rtlCol="0" anchor="t"/>
+          <a:lstStyle/>
+          <a:p>
+            <a:pPr algn="l" indent="0" marL="0">
+              <a:spcAft>
+                <a:spcPts val="1600"/>
+              </a:spcAft>
+              <a:buNone/>
+            </a:pPr>
+            <a:r>
+              <a:rPr lang="en-US" sz="2000" dirty="0">
+                <a:solidFill>
+                  <a:srgbClr val="20242B"/>
+                </a:solidFill>
+                <a:latin typeface="Calibri" pitchFamily="34" charset="0"/>
+                <a:ea typeface="Calibri" pitchFamily="34" charset="-122"/>
+                <a:cs typeface="Calibri" pitchFamily="34" charset="-120"/>
+              </a:rPr>
+              <a:t>Er ersetzt den Turboprop auf Strecken bis 320 km.</a:t>
+            </a:r>
+            <a:endParaRPr lang="en-US" sz="2000" dirty="0"/>
+          </a:p>
+          <a:p>
+            <a:pPr algn="l" indent="0" marL="0">
+              <a:spcAft>
+                <a:spcPts val="1600"/>
+              </a:spcAft>
+              <a:buNone/>
+            </a:pPr>
+            <a:r>
+              <a:rPr lang="en-US" sz="2000" dirty="0">
+                <a:solidFill>
+                  <a:srgbClr val="20242B"/>
+                </a:solidFill>
+                <a:latin typeface="Calibri" pitchFamily="34" charset="0"/>
+                <a:ea typeface="Calibri" pitchFamily="34" charset="-122"/>
+                <a:cs typeface="Calibri" pitchFamily="34" charset="-120"/>
+              </a:rPr>
+              <a:t>Geladen wird in 40 Minuten.</a:t>
+            </a:r>
+            <a:endParaRPr lang="en-US" sz="2000" dirty="0"/>
+          </a:p>
+        </p:txBody>
+      </p:sp>
       <p:graphicFrame>
         <p:nvGraphicFramePr>
           <p:cNvPr id="4" name="Table 0"/>
@@ -3336,7 +3298,7 @@
           </p:nvPr>
         </p:nvGraphicFramePr>
         <p:xfrm>
-          <a:off x="609600" y="1524000"/>
+          <a:off x="4876800" y="1625600"/>
           <a:ext cx="6705600" cy="914400"/>
         </p:xfrm>
         <a:graphic>
@@ -3347,7 +3309,7 @@
                 <a:gridCol w="4267200"/>
                 <a:gridCol w="2438400"/>
               </a:tblGrid>
-              <a:tr h="508000">
+              <a:tr h="406400">
                 <a:tc>
                   <a:txBody>
                     <a:bodyPr/>
@@ -3393,6 +3355,9 @@
                       <a:headEnd type="none" w="med" len="med"/>
                       <a:tailEnd type="none" w="med" len="med"/>
                     </a:lnB>
+                    <a:solidFill>
+                      <a:srgbClr val="FFFFFF"/>
+                    </a:solidFill>
                   </a:tcPr>
                 </a:tc>
                 <a:tc>
@@ -3429,10 +3394,13 @@
                       <a:headEnd type="none" w="med" len="med"/>
                       <a:tailEnd type="none" w="med" len="med"/>
                     </a:lnB>
+                    <a:solidFill>
+                      <a:srgbClr val="FFFFFF"/>
+                    </a:solidFill>
                   </a:tcPr>
                 </a:tc>
               </a:tr>
-              <a:tr h="508000">
+              <a:tr h="406400">
                 <a:tc>
                   <a:txBody>
                     <a:bodyPr/>
@@ -3478,6 +3446,9 @@
                       <a:headEnd type="none" w="med" len="med"/>
                       <a:tailEnd type="none" w="med" len="med"/>
                     </a:lnB>
+                    <a:solidFill>
+                      <a:srgbClr val="FFFFFF"/>
+                    </a:solidFill>
                   </a:tcPr>
                 </a:tc>
                 <a:tc>
@@ -3525,10 +3496,13 @@
                       <a:headEnd type="none" w="med" len="med"/>
                       <a:tailEnd type="none" w="med" len="med"/>
                     </a:lnB>
+                    <a:solidFill>
+                      <a:srgbClr val="FFFFFF"/>
+                    </a:solidFill>
                   </a:tcPr>
                 </a:tc>
               </a:tr>
-              <a:tr h="508000">
+              <a:tr h="406400">
                 <a:tc>
                   <a:txBody>
                     <a:bodyPr/>
@@ -3574,6 +3548,9 @@
                       <a:headEnd type="none" w="med" len="med"/>
                       <a:tailEnd type="none" w="med" len="med"/>
                     </a:lnB>
+                    <a:solidFill>
+                      <a:srgbClr val="FFFFFF"/>
+                    </a:solidFill>
                   </a:tcPr>
                 </a:tc>
                 <a:tc>
@@ -3621,10 +3598,13 @@
                       <a:headEnd type="none" w="med" len="med"/>
                       <a:tailEnd type="none" w="med" len="med"/>
                     </a:lnB>
+                    <a:solidFill>
+                      <a:srgbClr val="FFFFFF"/>
+                    </a:solidFill>
                   </a:tcPr>
                 </a:tc>
               </a:tr>
-              <a:tr h="508000">
+              <a:tr h="406400">
                 <a:tc>
                   <a:txBody>
                     <a:bodyPr/>
@@ -3670,6 +3650,9 @@
                       <a:headEnd type="none" w="med" len="med"/>
                       <a:tailEnd type="none" w="med" len="med"/>
                     </a:lnB>
+                    <a:solidFill>
+                      <a:srgbClr val="FFFFFF"/>
+                    </a:solidFill>
                   </a:tcPr>
                 </a:tc>
                 <a:tc>
@@ -3717,10 +3700,13 @@
                       <a:headEnd type="none" w="med" len="med"/>
                       <a:tailEnd type="none" w="med" len="med"/>
                     </a:lnB>
+                    <a:solidFill>
+                      <a:srgbClr val="FFFFFF"/>
+                    </a:solidFill>
                   </a:tcPr>
                 </a:tc>
               </a:tr>
-              <a:tr h="508000">
+              <a:tr h="406400">
                 <a:tc>
                   <a:txBody>
                     <a:bodyPr/>
@@ -3766,6 +3752,9 @@
                       <a:headEnd type="none" w="med" len="med"/>
                       <a:tailEnd type="none" w="med" len="med"/>
                     </a:lnB>
+                    <a:solidFill>
+                      <a:srgbClr val="FFFFFF"/>
+                    </a:solidFill>
                   </a:tcPr>
                 </a:tc>
                 <a:tc>
@@ -3813,10 +3802,13 @@
                       <a:headEnd type="none" w="med" len="med"/>
                       <a:tailEnd type="none" w="med" len="med"/>
                     </a:lnB>
+                    <a:solidFill>
+                      <a:srgbClr val="FFFFFF"/>
+                    </a:solidFill>
                   </a:tcPr>
                 </a:tc>
               </a:tr>
-              <a:tr h="508000">
+              <a:tr h="406400">
                 <a:tc>
                   <a:txBody>
                     <a:bodyPr/>
@@ -3862,6 +3854,9 @@
                       <a:headEnd type="none" w="med" len="med"/>
                       <a:tailEnd type="none" w="med" len="med"/>
                     </a:lnB>
+                    <a:solidFill>
+                      <a:srgbClr val="FFFFFF"/>
+                    </a:solidFill>
                   </a:tcPr>
                 </a:tc>
                 <a:tc>
@@ -3909,6 +3904,9 @@
                       <a:headEnd type="none" w="med" len="med"/>
                       <a:tailEnd type="none" w="med" len="med"/>
                     </a:lnB>
+                    <a:solidFill>
+                      <a:srgbClr val="FFFFFF"/>
+                    </a:solidFill>
                   </a:tcPr>
                 </a:tc>
               </a:tr>
@@ -3918,56 +3916,61 @@
       </p:graphicFrame>
       <p:sp>
         <p:nvSpPr>
-          <p:cNvPr id="4" name="Text 1"/>
-          <p:cNvSpPr txBox="1"/>
+          <p:cNvPr id="5" name="Shape 2"/>
+          <p:cNvSpPr/>
           <p:nvPr/>
         </p:nvSpPr>
         <p:spPr>
           <a:xfrm>
-            <a:off x="7924800" y="1625600"/>
-            <a:ext cx="3657600" cy="1016000"/>
+            <a:off x="609600" y="5384800"/>
+            <a:ext cx="3759200" cy="0"/>
+          </a:xfrm>
+          <a:prstGeom prst="line">
+            <a:avLst/>
+          </a:prstGeom>
+          <a:noFill/>
+          <a:ln w="25400">
+            <a:solidFill>
+              <a:srgbClr val="D3D6DB"/>
+            </a:solidFill>
+            <a:prstDash val="dash"/>
+          </a:ln>
+        </p:spPr>
+      </p:sp>
+      <p:pic>
+        <p:nvPicPr>
+          <p:cNvPr id="6" name="Image 0" descr="Kleines Flugzeug auf einer Fortschrittsleiste: je weiter rechts, desto weiter ist der Vortrag.">    </p:cNvPr>
+          <p:cNvPicPr>
+            <a:picLocks noChangeAspect="1"/>
+          </p:cNvPicPr>
+          <p:nvPr/>
+        </p:nvPicPr>
+        <p:blipFill>
+          <a:blip r:embed="rId1"/>
+          <a:stretch>
+            <a:fillRect/>
+          </a:stretch>
+        </p:blipFill>
+        <p:spPr>
+          <a:xfrm>
+            <a:off x="609600" y="5130800"/>
+            <a:ext cx="508000" cy="508000"/>
           </a:xfrm>
           <a:prstGeom prst="rect">
             <a:avLst/>
           </a:prstGeom>
-          <a:noFill/>
-          <a:ln/>
         </p:spPr>
-        <p:txBody>
-          <a:bodyPr wrap="square" lIns="0" tIns="0" rIns="0" bIns="0" rtlCol="0" anchor="t"/>
-          <a:lstStyle/>
-          <a:p>
-            <a:pPr algn="l" indent="0" marL="0">
-              <a:spcAft>
-                <a:spcPts val="1600"/>
-              </a:spcAft>
-              <a:buNone/>
-            </a:pPr>
-            <a:r>
-              <a:rPr lang="en-US" sz="2000" dirty="0">
-                <a:solidFill>
-                  <a:srgbClr val="20242B"/>
-                </a:solidFill>
-                <a:latin typeface="Calibri" pitchFamily="34" charset="0"/>
-                <a:ea typeface="Calibri" pitchFamily="34" charset="-122"/>
-                <a:cs typeface="Calibri" pitchFamily="34" charset="-120"/>
-              </a:rPr>
-              <a:t>Er ersetzt den Turboprop auf Strecken bis 320 km.</a:t>
-            </a:r>
-            <a:endParaRPr lang="en-US" sz="2000" dirty="0"/>
-          </a:p>
-        </p:txBody>
-      </p:sp>
-      <p:sp>
-        <p:nvSpPr>
-          <p:cNvPr id="5" name="Text 2"/>
+      </p:pic>
+      <p:sp>
+        <p:nvSpPr>
+          <p:cNvPr id="7" name="Text 3"/>
           <p:cNvSpPr txBox="1"/>
           <p:nvPr/>
         </p:nvSpPr>
         <p:spPr>
           <a:xfrm>
             <a:off x="609600" y="5791200"/>
-            <a:ext cx="9753600" cy="304800"/>
+            <a:ext cx="4267200" cy="203200"/>
           </a:xfrm>
           <a:prstGeom prst="rect">
             <a:avLst/>
@@ -4111,32 +4114,16 @@
           </a:p>
         </p:txBody>
       </p:sp>
-      <p:graphicFrame>
-        <p:nvGraphicFramePr>
-          <p:cNvPr id="3" name="Chart 0" descr="Flugdistanz der acht Testflüge in km: 18, 35, 60, 92, 130, 165, 190 und 212. Der letzte Flug ist hervorgehoben."/>
-          <p:cNvGraphicFramePr/>
-          <p:nvPr/>
-        </p:nvGraphicFramePr>
-        <p:xfrm>
-          <a:off x="609600" y="1524000"/>
-          <a:ext cx="6705600" cy="3048000"/>
-        </p:xfrm>
-        <a:graphic xmlns:a="http://schemas.openxmlformats.org/drawingml/2006/main">
-          <a:graphicData uri="http://schemas.openxmlformats.org/drawingml/2006/chart">
-            <c:chart xmlns:c="http://schemas.openxmlformats.org/drawingml/2006/chart" r:id="rId1"/>
-          </a:graphicData>
-        </a:graphic>
-      </p:graphicFrame>
-      <p:sp>
-        <p:nvSpPr>
-          <p:cNvPr id="4" name="Text 1"/>
+      <p:sp>
+        <p:nvSpPr>
+          <p:cNvPr id="3" name="Text 1"/>
           <p:cNvSpPr txBox="1"/>
           <p:nvPr/>
         </p:nvSpPr>
         <p:spPr>
           <a:xfrm>
-            <a:off x="8229600" y="1625600"/>
-            <a:ext cx="3352800" cy="1219200"/>
+            <a:off x="609600" y="1625600"/>
+            <a:ext cx="3759200" cy="914400"/>
           </a:xfrm>
           <a:prstGeom prst="rect">
             <a:avLst/>
@@ -4189,16 +4176,79 @@
           </a:p>
         </p:txBody>
       </p:sp>
-      <p:sp>
-        <p:nvSpPr>
-          <p:cNvPr id="5" name="Text 2"/>
+      <p:graphicFrame>
+        <p:nvGraphicFramePr>
+          <p:cNvPr id="4" name="Chart 0" descr="Flugdistanz der acht Testflüge in km: 18, 35, 60, 92, 130, 165, 190 und 212. Der letzte Flug ist hervorgehoben."/>
+          <p:cNvGraphicFramePr/>
+          <p:nvPr/>
+        </p:nvGraphicFramePr>
+        <p:xfrm>
+          <a:off x="4876800" y="1524000"/>
+          <a:ext cx="6705600" cy="3048000"/>
+        </p:xfrm>
+        <a:graphic xmlns:a="http://schemas.openxmlformats.org/drawingml/2006/main">
+          <a:graphicData uri="http://schemas.openxmlformats.org/drawingml/2006/chart">
+            <c:chart xmlns:c="http://schemas.openxmlformats.org/drawingml/2006/chart" r:id="rId1"/>
+          </a:graphicData>
+        </a:graphic>
+      </p:graphicFrame>
+      <p:sp>
+        <p:nvSpPr>
+          <p:cNvPr id="5" name="Shape 2"/>
+          <p:cNvSpPr/>
+          <p:nvPr/>
+        </p:nvSpPr>
+        <p:spPr>
+          <a:xfrm>
+            <a:off x="609600" y="5384800"/>
+            <a:ext cx="3759200" cy="0"/>
+          </a:xfrm>
+          <a:prstGeom prst="line">
+            <a:avLst/>
+          </a:prstGeom>
+          <a:noFill/>
+          <a:ln w="25400">
+            <a:solidFill>
+              <a:srgbClr val="D3D6DB"/>
+            </a:solidFill>
+            <a:prstDash val="dash"/>
+          </a:ln>
+        </p:spPr>
+      </p:sp>
+      <p:pic>
+        <p:nvPicPr>
+          <p:cNvPr id="6" name="Image 0" descr="Kleines Flugzeug auf einer Fortschrittsleiste: je weiter rechts, desto weiter ist der Vortrag.">    </p:cNvPr>
+          <p:cNvPicPr>
+            <a:picLocks noChangeAspect="1"/>
+          </p:cNvPicPr>
+          <p:nvPr/>
+        </p:nvPicPr>
+        <p:blipFill>
+          <a:blip r:embed="rId2"/>
+          <a:stretch>
+            <a:fillRect/>
+          </a:stretch>
+        </p:blipFill>
+        <p:spPr>
+          <a:xfrm>
+            <a:off x="1259840" y="5130800"/>
+            <a:ext cx="508000" cy="508000"/>
+          </a:xfrm>
+          <a:prstGeom prst="rect">
+            <a:avLst/>
+          </a:prstGeom>
+        </p:spPr>
+      </p:pic>
+      <p:sp>
+        <p:nvSpPr>
+          <p:cNvPr id="7" name="Text 3"/>
           <p:cNvSpPr txBox="1"/>
           <p:nvPr/>
         </p:nvSpPr>
         <p:spPr>
           <a:xfrm>
             <a:off x="609600" y="5791200"/>
-            <a:ext cx="9753600" cy="304800"/>
+            <a:ext cx="4267200" cy="203200"/>
           </a:xfrm>
           <a:prstGeom prst="rect">
             <a:avLst/>
@@ -4342,32 +4392,16 @@
           </a:p>
         </p:txBody>
       </p:sp>
-      <p:graphicFrame>
-        <p:nvGraphicFramePr>
-          <p:cNvPr id="3" name="Chart 0" descr="Marktvolumen in Mrd. Euro: Regionalflüge Europa 21, davon unter 320 km 8,4, erreichbar bis 2032: 1,1. Der erreichbare Teil ist hervorgehoben."/>
-          <p:cNvGraphicFramePr/>
-          <p:nvPr/>
-        </p:nvGraphicFramePr>
-        <p:xfrm>
-          <a:off x="609600" y="1524000"/>
-          <a:ext cx="6705600" cy="2844800"/>
-        </p:xfrm>
-        <a:graphic xmlns:a="http://schemas.openxmlformats.org/drawingml/2006/main">
-          <a:graphicData uri="http://schemas.openxmlformats.org/drawingml/2006/chart">
-            <c:chart xmlns:c="http://schemas.openxmlformats.org/drawingml/2006/chart" r:id="rId1"/>
-          </a:graphicData>
-        </a:graphic>
-      </p:graphicFrame>
-      <p:sp>
-        <p:nvSpPr>
-          <p:cNvPr id="4" name="Text 1"/>
+      <p:sp>
+        <p:nvSpPr>
+          <p:cNvPr id="3" name="Text 1"/>
           <p:cNvSpPr txBox="1"/>
           <p:nvPr/>
         </p:nvSpPr>
         <p:spPr>
           <a:xfrm>
-            <a:off x="8229600" y="1625600"/>
-            <a:ext cx="3352800" cy="914400"/>
+            <a:off x="609600" y="1625600"/>
+            <a:ext cx="3759200" cy="914400"/>
           </a:xfrm>
           <a:prstGeom prst="rect">
             <a:avLst/>
@@ -4398,18 +4432,101 @@
             </a:r>
             <a:endParaRPr lang="en-US" sz="2000" dirty="0"/>
           </a:p>
+          <a:p>
+            <a:pPr algn="l" indent="0" marL="0">
+              <a:spcAft>
+                <a:spcPts val="1600"/>
+              </a:spcAft>
+              <a:buNone/>
+            </a:pPr>
+            <a:r>
+              <a:rPr lang="en-US" sz="2000" dirty="0">
+                <a:solidFill>
+                  <a:srgbClr val="20242B"/>
+                </a:solidFill>
+                <a:latin typeface="Calibri" pitchFamily="34" charset="0"/>
+                <a:ea typeface="Calibri" pitchFamily="34" charset="-122"/>
+                <a:cs typeface="Calibri" pitchFamily="34" charset="-120"/>
+              </a:rPr>
+              <a:t>Bis 2032 erreichbar: 1,1 Mrd. €.</a:t>
+            </a:r>
+            <a:endParaRPr lang="en-US" sz="2000" dirty="0"/>
+          </a:p>
         </p:txBody>
       </p:sp>
-      <p:sp>
-        <p:nvSpPr>
-          <p:cNvPr id="5" name="Text 2"/>
+      <p:graphicFrame>
+        <p:nvGraphicFramePr>
+          <p:cNvPr id="4" name="Chart 0" descr="Marktvolumen in Mrd. Euro: Regionalflüge Europa 21, davon unter 320 km 8,4, erreichbar bis 2032: 1,1. Der erreichbare Teil ist hervorgehoben."/>
+          <p:cNvGraphicFramePr/>
+          <p:nvPr/>
+        </p:nvGraphicFramePr>
+        <p:xfrm>
+          <a:off x="4876800" y="1524000"/>
+          <a:ext cx="6705600" cy="2946400"/>
+        </p:xfrm>
+        <a:graphic xmlns:a="http://schemas.openxmlformats.org/drawingml/2006/main">
+          <a:graphicData uri="http://schemas.openxmlformats.org/drawingml/2006/chart">
+            <c:chart xmlns:c="http://schemas.openxmlformats.org/drawingml/2006/chart" r:id="rId1"/>
+          </a:graphicData>
+        </a:graphic>
+      </p:graphicFrame>
+      <p:sp>
+        <p:nvSpPr>
+          <p:cNvPr id="5" name="Shape 2"/>
+          <p:cNvSpPr/>
+          <p:nvPr/>
+        </p:nvSpPr>
+        <p:spPr>
+          <a:xfrm>
+            <a:off x="609600" y="5384800"/>
+            <a:ext cx="3759200" cy="0"/>
+          </a:xfrm>
+          <a:prstGeom prst="line">
+            <a:avLst/>
+          </a:prstGeom>
+          <a:noFill/>
+          <a:ln w="25400">
+            <a:solidFill>
+              <a:srgbClr val="D3D6DB"/>
+            </a:solidFill>
+            <a:prstDash val="dash"/>
+          </a:ln>
+        </p:spPr>
+      </p:sp>
+      <p:pic>
+        <p:nvPicPr>
+          <p:cNvPr id="6" name="Image 0" descr="Kleines Flugzeug auf einer Fortschrittsleiste: je weiter rechts, desto weiter ist der Vortrag.">    </p:cNvPr>
+          <p:cNvPicPr>
+            <a:picLocks noChangeAspect="1"/>
+          </p:cNvPicPr>
+          <p:nvPr/>
+        </p:nvPicPr>
+        <p:blipFill>
+          <a:blip r:embed="rId2"/>
+          <a:stretch>
+            <a:fillRect/>
+          </a:stretch>
+        </p:blipFill>
+        <p:spPr>
+          <a:xfrm>
+            <a:off x="1910080" y="5130800"/>
+            <a:ext cx="508000" cy="508000"/>
+          </a:xfrm>
+          <a:prstGeom prst="rect">
+            <a:avLst/>
+          </a:prstGeom>
+        </p:spPr>
+      </p:pic>
+      <p:sp>
+        <p:nvSpPr>
+          <p:cNvPr id="7" name="Text 3"/>
           <p:cNvSpPr txBox="1"/>
           <p:nvPr/>
         </p:nvSpPr>
         <p:spPr>
           <a:xfrm>
             <a:off x="609600" y="5791200"/>
-            <a:ext cx="9753600" cy="304800"/>
+            <a:ext cx="4267200" cy="203200"/>
           </a:xfrm>
           <a:prstGeom prst="rect">
             <a:avLst/>
@@ -4553,6 +4670,68 @@
           </a:p>
         </p:txBody>
       </p:sp>
+      <p:sp>
+        <p:nvSpPr>
+          <p:cNvPr id="3" name="Text 1"/>
+          <p:cNvSpPr txBox="1"/>
+          <p:nvPr/>
+        </p:nvSpPr>
+        <p:spPr>
+          <a:xfrm>
+            <a:off x="609600" y="1625600"/>
+            <a:ext cx="3759200" cy="1524000"/>
+          </a:xfrm>
+          <a:prstGeom prst="rect">
+            <a:avLst/>
+          </a:prstGeom>
+          <a:noFill/>
+          <a:ln/>
+        </p:spPr>
+        <p:txBody>
+          <a:bodyPr wrap="square" lIns="0" tIns="0" rIns="0" bIns="0" rtlCol="0" anchor="t"/>
+          <a:lstStyle/>
+          <a:p>
+            <a:pPr algn="l" indent="0" marL="0">
+              <a:spcAft>
+                <a:spcPts val="1600"/>
+              </a:spcAft>
+              <a:buNone/>
+            </a:pPr>
+            <a:r>
+              <a:rPr lang="en-US" sz="2000" dirty="0">
+                <a:solidFill>
+                  <a:srgbClr val="20242B"/>
+                </a:solidFill>
+                <a:latin typeface="Calibri" pitchFamily="34" charset="0"/>
+                <a:ea typeface="Calibri" pitchFamily="34" charset="-122"/>
+                <a:cs typeface="Calibri" pitchFamily="34" charset="-120"/>
+              </a:rPr>
+              <a:t>Der Verkauf bringt 62 % vom Umsatz.</a:t>
+            </a:r>
+            <a:endParaRPr lang="en-US" sz="2000" dirty="0"/>
+          </a:p>
+          <a:p>
+            <a:pPr algn="l" indent="0" marL="0">
+              <a:spcAft>
+                <a:spcPts val="1600"/>
+              </a:spcAft>
+              <a:buNone/>
+            </a:pPr>
+            <a:r>
+              <a:rPr lang="en-US" sz="2000" dirty="0">
+                <a:solidFill>
+                  <a:srgbClr val="20242B"/>
+                </a:solidFill>
+                <a:latin typeface="Calibri" pitchFamily="34" charset="0"/>
+                <a:ea typeface="Calibri" pitchFamily="34" charset="-122"/>
+                <a:cs typeface="Calibri" pitchFamily="34" charset="-120"/>
+              </a:rPr>
+              <a:t>Die Wartung bringt 41 % Marge.</a:t>
+            </a:r>
+            <a:endParaRPr lang="en-US" sz="2000" dirty="0"/>
+          </a:p>
+        </p:txBody>
+      </p:sp>
       <p:graphicFrame>
         <p:nvGraphicFramePr>
           <p:cNvPr id="7" name="Table 0"/>
@@ -4568,17 +4747,17 @@
           </p:nvPr>
         </p:nvGraphicFramePr>
         <p:xfrm>
-          <a:off x="609600" y="1524000"/>
-          <a:ext cx="10972800" cy="914400"/>
+          <a:off x="4876800" y="1625600"/>
+          <a:ext cx="6705600" cy="914400"/>
         </p:xfrm>
         <a:graphic>
           <a:graphicData uri="http://schemas.openxmlformats.org/drawingml/2006/table">
             <a:tbl>
               <a:tblPr/>
               <a:tblGrid>
-                <a:gridCol w="6096000"/>
-                <a:gridCol w="2438400"/>
-                <a:gridCol w="2438400"/>
+                <a:gridCol w="2946400"/>
+                <a:gridCol w="1981200"/>
+                <a:gridCol w="1778000"/>
               </a:tblGrid>
               <a:tr h="508000">
                 <a:tc>
@@ -4626,6 +4805,9 @@
                       <a:headEnd type="none" w="med" len="med"/>
                       <a:tailEnd type="none" w="med" len="med"/>
                     </a:lnB>
+                    <a:solidFill>
+                      <a:srgbClr val="FFFFFF"/>
+                    </a:solidFill>
                   </a:tcPr>
                 </a:tc>
                 <a:tc>
@@ -4673,6 +4855,9 @@
                       <a:headEnd type="none" w="med" len="med"/>
                       <a:tailEnd type="none" w="med" len="med"/>
                     </a:lnB>
+                    <a:solidFill>
+                      <a:srgbClr val="FFFFFF"/>
+                    </a:solidFill>
                   </a:tcPr>
                 </a:tc>
                 <a:tc>
@@ -4720,6 +4905,9 @@
                       <a:headEnd type="none" w="med" len="med"/>
                       <a:tailEnd type="none" w="med" len="med"/>
                     </a:lnB>
+                    <a:solidFill>
+                      <a:srgbClr val="FFFFFF"/>
+                    </a:solidFill>
                   </a:tcPr>
                 </a:tc>
               </a:tr>
@@ -4769,6 +4957,9 @@
                       <a:headEnd type="none" w="med" len="med"/>
                       <a:tailEnd type="none" w="med" len="med"/>
                     </a:lnB>
+                    <a:solidFill>
+                      <a:srgbClr val="FFFFFF"/>
+                    </a:solidFill>
                   </a:tcPr>
                 </a:tc>
                 <a:tc>
@@ -4816,6 +5007,9 @@
                       <a:headEnd type="none" w="med" len="med"/>
                       <a:tailEnd type="none" w="med" len="med"/>
                     </a:lnB>
+                    <a:solidFill>
+                      <a:srgbClr val="FFFFFF"/>
+                    </a:solidFill>
                   </a:tcPr>
                 </a:tc>
                 <a:tc>
@@ -4863,6 +5057,9 @@
                       <a:headEnd type="none" w="med" len="med"/>
                       <a:tailEnd type="none" w="med" len="med"/>
                     </a:lnB>
+                    <a:solidFill>
+                      <a:srgbClr val="FFFFFF"/>
+                    </a:solidFill>
                   </a:tcPr>
                 </a:tc>
               </a:tr>
@@ -4912,6 +5109,9 @@
                       <a:headEnd type="none" w="med" len="med"/>
                       <a:tailEnd type="none" w="med" len="med"/>
                     </a:lnB>
+                    <a:solidFill>
+                      <a:srgbClr val="FFFFFF"/>
+                    </a:solidFill>
                   </a:tcPr>
                 </a:tc>
                 <a:tc>
@@ -4959,6 +5159,9 @@
                       <a:headEnd type="none" w="med" len="med"/>
                       <a:tailEnd type="none" w="med" len="med"/>
                     </a:lnB>
+                    <a:solidFill>
+                      <a:srgbClr val="FFFFFF"/>
+                    </a:solidFill>
                   </a:tcPr>
                 </a:tc>
                 <a:tc>
@@ -5006,6 +5209,9 @@
                       <a:headEnd type="none" w="med" len="med"/>
                       <a:tailEnd type="none" w="med" len="med"/>
                     </a:lnB>
+                    <a:solidFill>
+                      <a:srgbClr val="FFFFFF"/>
+                    </a:solidFill>
                   </a:tcPr>
                 </a:tc>
               </a:tr>
@@ -5055,6 +5261,9 @@
                       <a:headEnd type="none" w="med" len="med"/>
                       <a:tailEnd type="none" w="med" len="med"/>
                     </a:lnB>
+                    <a:solidFill>
+                      <a:srgbClr val="FFFFFF"/>
+                    </a:solidFill>
                   </a:tcPr>
                 </a:tc>
                 <a:tc>
@@ -5102,6 +5311,9 @@
                       <a:headEnd type="none" w="med" len="med"/>
                       <a:tailEnd type="none" w="med" len="med"/>
                     </a:lnB>
+                    <a:solidFill>
+                      <a:srgbClr val="FFFFFF"/>
+                    </a:solidFill>
                   </a:tcPr>
                 </a:tc>
                 <a:tc>
@@ -5149,6 +5361,9 @@
                       <a:headEnd type="none" w="med" len="med"/>
                       <a:tailEnd type="none" w="med" len="med"/>
                     </a:lnB>
+                    <a:solidFill>
+                      <a:srgbClr val="FFFFFF"/>
+                    </a:solidFill>
                   </a:tcPr>
                 </a:tc>
               </a:tr>
@@ -5158,14 +5373,61 @@
       </p:graphicFrame>
       <p:sp>
         <p:nvSpPr>
-          <p:cNvPr id="4" name="Text 1"/>
+          <p:cNvPr id="5" name="Shape 2"/>
+          <p:cNvSpPr/>
+          <p:nvPr/>
+        </p:nvSpPr>
+        <p:spPr>
+          <a:xfrm>
+            <a:off x="609600" y="5384800"/>
+            <a:ext cx="3759200" cy="0"/>
+          </a:xfrm>
+          <a:prstGeom prst="line">
+            <a:avLst/>
+          </a:prstGeom>
+          <a:noFill/>
+          <a:ln w="25400">
+            <a:solidFill>
+              <a:srgbClr val="D3D6DB"/>
+            </a:solidFill>
+            <a:prstDash val="dash"/>
+          </a:ln>
+        </p:spPr>
+      </p:sp>
+      <p:pic>
+        <p:nvPicPr>
+          <p:cNvPr id="6" name="Image 0" descr="Kleines Flugzeug auf einer Fortschrittsleiste: je weiter rechts, desto weiter ist der Vortrag.">    </p:cNvPr>
+          <p:cNvPicPr>
+            <a:picLocks noChangeAspect="1"/>
+          </p:cNvPicPr>
+          <p:nvPr/>
+        </p:nvPicPr>
+        <p:blipFill>
+          <a:blip r:embed="rId1"/>
+          <a:stretch>
+            <a:fillRect/>
+          </a:stretch>
+        </p:blipFill>
+        <p:spPr>
+          <a:xfrm>
+            <a:off x="2560320" y="5130800"/>
+            <a:ext cx="508000" cy="508000"/>
+          </a:xfrm>
+          <a:prstGeom prst="rect">
+            <a:avLst/>
+          </a:prstGeom>
+        </p:spPr>
+      </p:pic>
+      <p:sp>
+        <p:nvSpPr>
+          <p:cNvPr id="7" name="Text 3"/>
           <p:cNvSpPr txBox="1"/>
           <p:nvPr/>
         </p:nvSpPr>
         <p:spPr>
           <a:xfrm>
             <a:off x="609600" y="5791200"/>
-            <a:ext cx="9753600" cy="304800"/>
+            <a:ext cx="4267200" cy="203200"/>
           </a:xfrm>
           <a:prstGeom prst="rect">
             <a:avLst/>
@@ -5324,7 +5586,7 @@
           </p:nvPr>
         </p:nvGraphicFramePr>
         <p:xfrm>
-          <a:off x="609600" y="1524000"/>
+          <a:off x="609600" y="1625600"/>
           <a:ext cx="10972800" cy="914400"/>
         </p:xfrm>
         <a:graphic>
@@ -5382,6 +5644,9 @@
                       <a:headEnd type="none" w="med" len="med"/>
                       <a:tailEnd type="none" w="med" len="med"/>
                     </a:lnB>
+                    <a:solidFill>
+                      <a:srgbClr val="FFFFFF"/>
+                    </a:solidFill>
                   </a:tcPr>
                 </a:tc>
                 <a:tc>
@@ -5429,6 +5694,9 @@
                       <a:headEnd type="none" w="med" len="med"/>
                       <a:tailEnd type="none" w="med" len="med"/>
                     </a:lnB>
+                    <a:solidFill>
+                      <a:srgbClr val="FFFFFF"/>
+                    </a:solidFill>
                   </a:tcPr>
                 </a:tc>
                 <a:tc>
@@ -5476,6 +5744,9 @@
                       <a:headEnd type="none" w="med" len="med"/>
                       <a:tailEnd type="none" w="med" len="med"/>
                     </a:lnB>
+                    <a:solidFill>
+                      <a:srgbClr val="FFFFFF"/>
+                    </a:solidFill>
                   </a:tcPr>
                 </a:tc>
               </a:tr>
@@ -5525,6 +5796,9 @@
                       <a:headEnd type="none" w="med" len="med"/>
                       <a:tailEnd type="none" w="med" len="med"/>
                     </a:lnB>
+                    <a:solidFill>
+                      <a:srgbClr val="FFFFFF"/>
+                    </a:solidFill>
                   </a:tcPr>
                 </a:tc>
                 <a:tc>
@@ -5572,6 +5846,9 @@
                       <a:headEnd type="none" w="med" len="med"/>
                       <a:tailEnd type="none" w="med" len="med"/>
                     </a:lnB>
+                    <a:solidFill>
+                      <a:srgbClr val="FFFFFF"/>
+                    </a:solidFill>
                   </a:tcPr>
                 </a:tc>
                 <a:tc>
@@ -5619,6 +5896,9 @@
                       <a:headEnd type="none" w="med" len="med"/>
                       <a:tailEnd type="none" w="med" len="med"/>
                     </a:lnB>
+                    <a:solidFill>
+                      <a:srgbClr val="FFFFFF"/>
+                    </a:solidFill>
                   </a:tcPr>
                 </a:tc>
               </a:tr>
@@ -5668,6 +5948,9 @@
                       <a:headEnd type="none" w="med" len="med"/>
                       <a:tailEnd type="none" w="med" len="med"/>
                     </a:lnB>
+                    <a:solidFill>
+                      <a:srgbClr val="FFFFFF"/>
+                    </a:solidFill>
                   </a:tcPr>
                 </a:tc>
                 <a:tc>
@@ -5715,6 +5998,9 @@
                       <a:headEnd type="none" w="med" len="med"/>
                       <a:tailEnd type="none" w="med" len="med"/>
                     </a:lnB>
+                    <a:solidFill>
+                      <a:srgbClr val="FFFFFF"/>
+                    </a:solidFill>
                   </a:tcPr>
                 </a:tc>
                 <a:tc>
@@ -5762,6 +6048,9 @@
                       <a:headEnd type="none" w="med" len="med"/>
                       <a:tailEnd type="none" w="med" len="med"/>
                     </a:lnB>
+                    <a:solidFill>
+                      <a:srgbClr val="FFFFFF"/>
+                    </a:solidFill>
                   </a:tcPr>
                 </a:tc>
               </a:tr>
@@ -5811,6 +6100,9 @@
                       <a:headEnd type="none" w="med" len="med"/>
                       <a:tailEnd type="none" w="med" len="med"/>
                     </a:lnB>
+                    <a:solidFill>
+                      <a:srgbClr val="FFFFFF"/>
+                    </a:solidFill>
                   </a:tcPr>
                 </a:tc>
                 <a:tc>
@@ -5858,6 +6150,9 @@
                       <a:headEnd type="none" w="med" len="med"/>
                       <a:tailEnd type="none" w="med" len="med"/>
                     </a:lnB>
+                    <a:solidFill>
+                      <a:srgbClr val="FFFFFF"/>
+                    </a:solidFill>
                   </a:tcPr>
                 </a:tc>
                 <a:tc>
@@ -5905,6 +6200,9 @@
                       <a:headEnd type="none" w="med" len="med"/>
                       <a:tailEnd type="none" w="med" len="med"/>
                     </a:lnB>
+                    <a:solidFill>
+                      <a:srgbClr val="FFFFFF"/>
+                    </a:solidFill>
                   </a:tcPr>
                 </a:tc>
               </a:tr>
@@ -5914,14 +6212,61 @@
       </p:graphicFrame>
       <p:sp>
         <p:nvSpPr>
-          <p:cNvPr id="4" name="Text 1"/>
+          <p:cNvPr id="4" name="Shape 1"/>
+          <p:cNvSpPr/>
+          <p:nvPr/>
+        </p:nvSpPr>
+        <p:spPr>
+          <a:xfrm>
+            <a:off x="609600" y="5384800"/>
+            <a:ext cx="3759200" cy="0"/>
+          </a:xfrm>
+          <a:prstGeom prst="line">
+            <a:avLst/>
+          </a:prstGeom>
+          <a:noFill/>
+          <a:ln w="25400">
+            <a:solidFill>
+              <a:srgbClr val="D3D6DB"/>
+            </a:solidFill>
+            <a:prstDash val="dash"/>
+          </a:ln>
+        </p:spPr>
+      </p:sp>
+      <p:pic>
+        <p:nvPicPr>
+          <p:cNvPr id="5" name="Image 0" descr="Kleines Flugzeug auf einer Fortschrittsleiste: je weiter rechts, desto weiter ist der Vortrag.">    </p:cNvPr>
+          <p:cNvPicPr>
+            <a:picLocks noChangeAspect="1"/>
+          </p:cNvPicPr>
+          <p:nvPr/>
+        </p:nvPicPr>
+        <p:blipFill>
+          <a:blip r:embed="rId1"/>
+          <a:stretch>
+            <a:fillRect/>
+          </a:stretch>
+        </p:blipFill>
+        <p:spPr>
+          <a:xfrm>
+            <a:off x="3210560" y="5130800"/>
+            <a:ext cx="508000" cy="508000"/>
+          </a:xfrm>
+          <a:prstGeom prst="rect">
+            <a:avLst/>
+          </a:prstGeom>
+        </p:spPr>
+      </p:pic>
+      <p:sp>
+        <p:nvSpPr>
+          <p:cNvPr id="6" name="Text 2"/>
           <p:cNvSpPr txBox="1"/>
           <p:nvPr/>
         </p:nvSpPr>
         <p:spPr>
           <a:xfrm>
             <a:off x="609600" y="5791200"/>
-            <a:ext cx="9753600" cy="304800"/>
+            <a:ext cx="4267200" cy="203200"/>
           </a:xfrm>
           <a:prstGeom prst="rect">
             <a:avLst/>
@@ -6065,32 +6410,16 @@
           </a:p>
         </p:txBody>
       </p:sp>
-      <p:graphicFrame>
-        <p:nvGraphicFramePr>
-          <p:cNvPr id="3" name="Chart 0" descr="Mittelverwendung in Mio. Euro: Zulassung 8, Serienvorbereitung 6, Team 4. Die Zulassung ist hervorgehoben."/>
-          <p:cNvGraphicFramePr/>
-          <p:nvPr/>
-        </p:nvGraphicFramePr>
-        <p:xfrm>
-          <a:off x="609600" y="1524000"/>
-          <a:ext cx="6705600" cy="2641600"/>
-        </p:xfrm>
-        <a:graphic xmlns:a="http://schemas.openxmlformats.org/drawingml/2006/main">
-          <a:graphicData uri="http://schemas.openxmlformats.org/drawingml/2006/chart">
-            <c:chart xmlns:c="http://schemas.openxmlformats.org/drawingml/2006/chart" r:id="rId1"/>
-          </a:graphicData>
-        </a:graphic>
-      </p:graphicFrame>
-      <p:sp>
-        <p:nvSpPr>
-          <p:cNvPr id="4" name="Text 1"/>
+      <p:sp>
+        <p:nvSpPr>
+          <p:cNvPr id="3" name="Text 1"/>
           <p:cNvSpPr txBox="1"/>
           <p:nvPr/>
         </p:nvSpPr>
         <p:spPr>
           <a:xfrm>
-            <a:off x="8229600" y="1625600"/>
-            <a:ext cx="3352800" cy="914400"/>
+            <a:off x="609600" y="1625600"/>
+            <a:ext cx="3759200" cy="711200"/>
           </a:xfrm>
           <a:prstGeom prst="rect">
             <a:avLst/>
@@ -6123,16 +6452,79 @@
           </a:p>
         </p:txBody>
       </p:sp>
-      <p:sp>
-        <p:nvSpPr>
-          <p:cNvPr id="5" name="Text 2"/>
+      <p:graphicFrame>
+        <p:nvGraphicFramePr>
+          <p:cNvPr id="4" name="Chart 0" descr="Mittelverwendung in Mio. Euro: Zulassung 8, Serienvorbereitung 6, Team 4. Die Zulassung ist hervorgehoben."/>
+          <p:cNvGraphicFramePr/>
+          <p:nvPr/>
+        </p:nvGraphicFramePr>
+        <p:xfrm>
+          <a:off x="4876800" y="1524000"/>
+          <a:ext cx="6705600" cy="2946400"/>
+        </p:xfrm>
+        <a:graphic xmlns:a="http://schemas.openxmlformats.org/drawingml/2006/main">
+          <a:graphicData uri="http://schemas.openxmlformats.org/drawingml/2006/chart">
+            <c:chart xmlns:c="http://schemas.openxmlformats.org/drawingml/2006/chart" r:id="rId1"/>
+          </a:graphicData>
+        </a:graphic>
+      </p:graphicFrame>
+      <p:sp>
+        <p:nvSpPr>
+          <p:cNvPr id="5" name="Shape 2"/>
+          <p:cNvSpPr/>
+          <p:nvPr/>
+        </p:nvSpPr>
+        <p:spPr>
+          <a:xfrm>
+            <a:off x="609600" y="5384800"/>
+            <a:ext cx="3759200" cy="0"/>
+          </a:xfrm>
+          <a:prstGeom prst="line">
+            <a:avLst/>
+          </a:prstGeom>
+          <a:noFill/>
+          <a:ln w="25400">
+            <a:solidFill>
+              <a:srgbClr val="D3D6DB"/>
+            </a:solidFill>
+            <a:prstDash val="dash"/>
+          </a:ln>
+        </p:spPr>
+      </p:sp>
+      <p:pic>
+        <p:nvPicPr>
+          <p:cNvPr id="6" name="Image 0" descr="Kleines Flugzeug auf einer Fortschrittsleiste: je weiter rechts, desto weiter ist der Vortrag.">    </p:cNvPr>
+          <p:cNvPicPr>
+            <a:picLocks noChangeAspect="1"/>
+          </p:cNvPicPr>
+          <p:nvPr/>
+        </p:nvPicPr>
+        <p:blipFill>
+          <a:blip r:embed="rId2"/>
+          <a:stretch>
+            <a:fillRect/>
+          </a:stretch>
+        </p:blipFill>
+        <p:spPr>
+          <a:xfrm>
+            <a:off x="3860800" y="5130800"/>
+            <a:ext cx="508000" cy="508000"/>
+          </a:xfrm>
+          <a:prstGeom prst="rect">
+            <a:avLst/>
+          </a:prstGeom>
+        </p:spPr>
+      </p:pic>
+      <p:sp>
+        <p:nvSpPr>
+          <p:cNvPr id="7" name="Text 3"/>
           <p:cNvSpPr txBox="1"/>
           <p:nvPr/>
         </p:nvSpPr>
         <p:spPr>
           <a:xfrm>
             <a:off x="609600" y="5791200"/>
-            <a:ext cx="9753600" cy="304800"/>
+            <a:ext cx="4267200" cy="203200"/>
           </a:xfrm>
           <a:prstGeom prst="rect">
             <a:avLst/>

</xml_diff>